<commit_message>
changes made in contribution file and 2 readme file
</commit_message>
<xml_diff>
--- a/presentation/RapidDeploy.pptx
+++ b/presentation/RapidDeploy.pptx
@@ -121,6 +121,11 @@
       </a:defRPr>
     </a:lvl9pPr>
   </p:defaultTextStyle>
+  <p:extLst>
+    <p:ext uri="{EFAFB233-063F-42B5-8137-9DF3F51BA10A}">
+      <p15:sldGuideLst xmlns:p15="http://schemas.microsoft.com/office/powerpoint/2012/main"/>
+    </p:ext>
+  </p:extLst>
 </p:presentation>
 </file>
 
@@ -489,7 +494,7 @@
           <a:p>
             <a:r>
               <a:rPr lang="en-US"/>
-              <a:t>Slide 1 - Title. RapidDeploy: Supply Chain and Cold-Chain Operations Dashboard. IBM Hackathon 2025.</a:t>
+              <a:t>Slide 1 - Title. RapidDeploy: Supply Chain and Cold-Chain Operations Dashboard. IBM Hackathon 2026.</a:t>
             </a:r>
           </a:p>
         </p:txBody>
@@ -819,7 +824,7 @@
           <a:p>
             <a:r>
               <a:rPr lang="en-US"/>
-              <a:t>Slide 14 - Team. Four members: Patel Dikshit (lead), Parekh Rudra, Patel Dhruv, Patel Jainil. Track: Open. IBM Hackathon 2025.</a:t>
+              <a:t>Slide 14 - Team. Four members: Patel Dikshit (lead), Parekh Rudra, Patel Dhruv, Patel Jainil. Track: Open. IBM Hackathon 2026.</a:t>
             </a:r>
           </a:p>
         </p:txBody>
@@ -951,7 +956,7 @@
           <a:p>
             <a:r>
               <a:rPr lang="en-US"/>
-              <a:t>Slide 2 - Agenda. Walk the audience through the 14 slides that cover the problem, solution, architecture, features, tech stack, demo, and team.</a:t>
+              <a:t>Slide 2 - Agenda. Walk the audience through the 15 slides that cover the problem, solution, architecture, features, tech stack, demo, limitations, and team.</a:t>
             </a:r>
           </a:p>
         </p:txBody>
@@ -5517,7 +5522,7 @@
                 <a:latin typeface="Segoe UI"/>
                 <a:ea typeface="Segoe UI"/>
               </a:rPr>
-              <a:t>11  Performance &amp; Metrics</a:t>
+              <a:t>11  Known Limitations &amp; Future Scope</a:t>
             </a:r>
           </a:p>
           <a:p>
@@ -5534,7 +5539,7 @@
                 <a:latin typeface="Segoe UI"/>
                 <a:ea typeface="Segoe UI"/>
               </a:rPr>
-              <a:t>12  Known Limitations</a:t>
+              <a:t>12  Meet the Team</a:t>
             </a:r>
           </a:p>
         </p:txBody>

</xml_diff>